<commit_message>
Week 3: 7 engineering fixes — temperature pin, guardrail hook, multi-turn attacks, latency scoring
- agent/pronto_agent.py: TEMPERATURE=0.0 default (PRONTO_TEMPERATURE override)
  so scans are reproducible; new run_turn_guarded() wires input/output
  guardrails around the untouched run_turn loop
- starter.py: guardrails labeled INPUT-SIDE/OUTPUT-SIDE; score() adds avg_ms
- READMEs: multi-turn attack requirement (via --chat), 'who guards the
  guard' stretch note, wife's-order over-block worked example, hard
  legitimate edge-case seeds, three-number guardrail framing
- deck slide 23: temperature=0 note (44 slides, layout intact)
</commit_message>
<xml_diff>
--- a/deck-work/week3-live-v3.pptx
+++ b/deck-work/week3-live-v3.pptx
@@ -11219,6 +11219,11 @@
           <a:p>
             <a:r>
               <a:t>    # promptfoo &gt;= 0.122: exec takes the command as a string id.</a:t>
+            </a:r>
+          </a:p>
+          <a:p>
+            <a:r>
+              <a:t>    # the agent pins temperature=0 (PRONTO_TEMPERATURE): same probes, same results, every run.</a:t>
             </a:r>
           </a:p>
           <a:p>

</xml_diff>